<commit_message>
docs: correct final interface evidence
</commit_message>
<xml_diff>
--- a/docs/presentation/fraudlens-bharat-final-capstone.pptx
+++ b/docs/presentation/fraudlens-bharat-final-capstone.pptx
@@ -4338,7 +4338,7 @@
                 </a:solidFill>
                 <a:latin typeface="Aptos"/>
               </a:rPr>
-              <a:t>379</a:t>
+              <a:t>355</a:t>
             </a:r>
           </a:p>
         </p:txBody>
@@ -4740,7 +4740,7 @@
               </a:defRPr>
             </a:pPr>
             <a:r>
-              <a:t>379 automated tests</a:t>
+              <a:t>355 automated tests</a:t>
             </a:r>
           </a:p>
           <a:p>
@@ -11633,7 +11633,7 @@
                 </a:solidFill>
                 <a:latin typeface="Aptos"/>
               </a:rPr>
-              <a:t>379</a:t>
+              <a:t>355</a:t>
             </a:r>
           </a:p>
         </p:txBody>

</xml_diff>

<commit_message>
docs: retire Streamlit presentation evidence
</commit_message>
<xml_diff>
--- a/docs/presentation/fraudlens-bharat-final-capstone.pptx
+++ b/docs/presentation/fraudlens-bharat-final-capstone.pptx
@@ -7560,7 +7560,7 @@
               </a:defRPr>
             </a:pPr>
             <a:r>
-              <a:t>FastAPI + Streamlit on one analysis service</a:t>
+              <a:t>Next.js + FastAPI on one analysis service</a:t>
             </a:r>
           </a:p>
           <a:p>
@@ -10037,6 +10037,7 @@
         </p:nvPicPr>
         <p:blipFill>
           <a:blip r:embed="rId2"/>
+          <a:srcRect t="9700" b="4586"/>
           <a:stretch>
             <a:fillRect/>
           </a:stretch>
@@ -11074,7 +11075,7 @@
                 <a:latin typeface="Aptos"/>
               </a:rPr>
               <a:t>FastAPI
-Streamlit
+Next.js
 Pydantic validation</a:t>
             </a:r>
           </a:p>
@@ -12519,7 +12520,7 @@
                 </a:solidFill>
                 <a:latin typeface="Aptos"/>
               </a:rPr>
-              <a:t>Storage starts off | Synthetic fixtures only | API and dashboard use the same service</a:t>
+              <a:t>Storage starts off | Synthetic fixtures only | Website and API use the same service</a:t>
             </a:r>
           </a:p>
         </p:txBody>

</xml_diff>

<commit_message>
docs: refresh final capstone deck evidence
</commit_message>
<xml_diff>
--- a/docs/presentation/fraudlens-bharat-final-capstone.pptx
+++ b/docs/presentation/fraudlens-bharat-final-capstone.pptx
@@ -4338,7 +4338,7 @@
                 </a:solidFill>
                 <a:latin typeface="Aptos"/>
               </a:rPr>
-              <a:t>355</a:t>
+              <a:t>358</a:t>
             </a:r>
           </a:p>
         </p:txBody>
@@ -4740,7 +4740,7 @@
               </a:defRPr>
             </a:pPr>
             <a:r>
-              <a:t>355 automated tests</a:t>
+              <a:t>358 automated tests</a:t>
             </a:r>
           </a:p>
           <a:p>
@@ -11634,7 +11634,7 @@
                 </a:solidFill>
                 <a:latin typeface="Aptos"/>
               </a:rPr>
-              <a:t>355</a:t>
+              <a:t>358</a:t>
             </a:r>
           </a:p>
         </p:txBody>

</xml_diff>